<commit_message>
Date + about git
</commit_message>
<xml_diff>
--- a/WorkStuff/Courses/Git/Git_Best_Practices/Git_Best_Practices.pptx
+++ b/WorkStuff/Courses/Git/Git_Best_Practices/Git_Best_Practices.pptx
@@ -24,21 +24,23 @@
   <p:notesSz cx="6934200" cy="9232900"/>
   <p:embeddedFontLst>
     <p:embeddedFont>
-      <p:font typeface="Merriweather" panose="020B0604020202020204" charset="0"/>
+      <p:font typeface="Amatic SC" pitchFamily="2" charset="-79"/>
       <p:regular r:id="rId14"/>
       <p:bold r:id="rId15"/>
-      <p:italic r:id="rId16"/>
-      <p:boldItalic r:id="rId17"/>
     </p:embeddedFont>
     <p:embeddedFont>
-      <p:font typeface="Amatic SC" panose="020B0604020202020204" charset="-79"/>
-      <p:regular r:id="rId18"/>
-      <p:bold r:id="rId19"/>
+      <p:font typeface="Merriweather" pitchFamily="2" charset="77"/>
+      <p:regular r:id="rId16"/>
+      <p:bold r:id="rId17"/>
+      <p:italic r:id="rId18"/>
+      <p:boldItalic r:id="rId19"/>
     </p:embeddedFont>
     <p:embeddedFont>
-      <p:font typeface="Source Code Pro" panose="020B0604020202020204" charset="0"/>
+      <p:font typeface="Source Code Pro" panose="020B0509030403020204" pitchFamily="49" charset="0"/>
       <p:regular r:id="rId20"/>
       <p:bold r:id="rId21"/>
+      <p:italic r:id="rId22"/>
+      <p:boldItalic r:id="rId23"/>
     </p:embeddedFont>
   </p:embeddedFontLst>
   <p:defaultTextStyle>
@@ -243,6 +245,22 @@
       </a:defRPr>
     </a:lvl9pPr>
   </p:defaultTextStyle>
+  <p:extLst>
+    <p:ext uri="{EFAFB233-063F-42B5-8137-9DF3F51BA10A}">
+      <p15:sldGuideLst xmlns:p15="http://schemas.microsoft.com/office/powerpoint/2012/main">
+        <p15:guide id="1" orient="horz" pos="2160">
+          <p15:clr>
+            <a:srgbClr val="A4A3A4"/>
+          </p15:clr>
+        </p15:guide>
+        <p15:guide id="2" pos="2880">
+          <p15:clr>
+            <a:srgbClr val="A4A3A4"/>
+          </p15:clr>
+        </p15:guide>
+      </p15:sldGuideLst>
+    </p:ext>
+  </p:extLst>
 </p:presentation>
 </file>
 
@@ -2913,7 +2931,7 @@
           <a:p>
             <a:fld id="{559FE8C8-AC97-4ADA-A254-8F11A723A69F}" type="datetimeFigureOut">
               <a:rPr lang="en-US" smtClean="0"/>
-              <a:t>6/25/2019</a:t>
+              <a:t>7/19/23</a:t>
             </a:fld>
             <a:endParaRPr lang="en-US"/>
           </a:p>
@@ -3334,7 +3352,7 @@
           <a:p>
             <a:fld id="{B88F23AA-34D9-4A18-A5A1-06793324E42C}" type="datetimeFigureOut">
               <a:rPr lang="en-US" smtClean="0"/>
-              <a:t>6/25/2019</a:t>
+              <a:t>7/19/23</a:t>
             </a:fld>
             <a:endParaRPr lang="en-US"/>
           </a:p>
@@ -3456,7 +3474,7 @@
           <a:p>
             <a:fld id="{8DA20C1D-75ED-450C-88C7-C497EA874E9C}" type="datetimeFigureOut">
               <a:rPr lang="en-US" smtClean="0"/>
-              <a:t>6/25/2019</a:t>
+              <a:t>7/19/23</a:t>
             </a:fld>
             <a:endParaRPr lang="en-US"/>
           </a:p>
@@ -4650,7 +4668,7 @@
           <a:p>
             <a:fld id="{FEFA0557-7C35-4D1D-B97A-95898D157B33}" type="datetimeFigureOut">
               <a:rPr lang="en-US" smtClean="0"/>
-              <a:t>6/25/2019</a:t>
+              <a:t>7/19/23</a:t>
             </a:fld>
             <a:endParaRPr lang="en-US"/>
           </a:p>
@@ -4936,7 +4954,7 @@
           <a:p>
             <a:fld id="{B236AB90-F632-4852-BC4B-53E103869F3D}" type="datetimeFigureOut">
               <a:rPr lang="en-US" smtClean="0"/>
-              <a:t>6/25/2019</a:t>
+              <a:t>7/19/23</a:t>
             </a:fld>
             <a:endParaRPr lang="en-US"/>
           </a:p>
@@ -5322,7 +5340,7 @@
           <a:p>
             <a:fld id="{12374C44-A702-4728-BB40-76FE555B9CF1}" type="datetimeFigureOut">
               <a:rPr lang="en-US" smtClean="0"/>
-              <a:t>6/25/2019</a:t>
+              <a:t>7/19/23</a:t>
             </a:fld>
             <a:endParaRPr lang="en-US"/>
           </a:p>
@@ -5535,7 +5553,7 @@
           <a:p>
             <a:fld id="{E1F32DF0-702E-431A-ADCF-2A06AC4E7F57}" type="datetimeFigureOut">
               <a:rPr lang="en-US" smtClean="0"/>
-              <a:t>6/25/2019</a:t>
+              <a:t>7/19/23</a:t>
             </a:fld>
             <a:endParaRPr lang="en-US"/>
           </a:p>
@@ -5839,7 +5857,7 @@
           <a:p>
             <a:fld id="{DBDC1F8B-7509-4E85-ABDB-3F1EEA772746}" type="datetimeFigureOut">
               <a:rPr lang="en-US" smtClean="0"/>
-              <a:t>6/25/2019</a:t>
+              <a:t>7/19/23</a:t>
             </a:fld>
             <a:endParaRPr lang="en-US"/>
           </a:p>
@@ -6131,7 +6149,7 @@
           <a:p>
             <a:fld id="{52C5D9E0-CA9E-46E5-9606-B0D66E683FEE}" type="datetimeFigureOut">
               <a:rPr lang="en-US" smtClean="0"/>
-              <a:t>6/25/2019</a:t>
+              <a:t>7/19/23</a:t>
             </a:fld>
             <a:endParaRPr lang="en-US"/>
           </a:p>
@@ -6705,7 +6723,7 @@
           <a:p>
             <a:fld id="{5BA37E64-D101-4693-B362-74BB0158B47B}" type="datetimeFigureOut">
               <a:rPr lang="en-US" smtClean="0"/>
-              <a:t>6/25/2019</a:t>
+              <a:t>7/19/23</a:t>
             </a:fld>
             <a:endParaRPr lang="en-US"/>
           </a:p>
@@ -6881,7 +6899,7 @@
           <a:p>
             <a:fld id="{FACA2033-B529-4F88-BF0F-C9E77C7AF715}" type="datetimeFigureOut">
               <a:rPr lang="en-US" smtClean="0"/>
-              <a:t>6/25/2019</a:t>
+              <a:t>7/19/23</a:t>
             </a:fld>
             <a:endParaRPr lang="en-US"/>
           </a:p>
@@ -7521,7 +7539,7 @@
           <a:p>
             <a:fld id="{2F850279-8577-4DB5-A1B1-2A1239DFFE30}" type="datetimeFigureOut">
               <a:rPr lang="en-US" smtClean="0"/>
-              <a:t>6/25/2019</a:t>
+              <a:t>7/19/23</a:t>
             </a:fld>
             <a:endParaRPr lang="en-US"/>
           </a:p>
@@ -8061,29 +8079,8 @@
                 <a:cs typeface="Merriweather"/>
                 <a:sym typeface="Merriweather"/>
               </a:rPr>
-              <a:t>Git </a:t>
+              <a:t>Git Best Practices</a:t>
             </a:r>
-            <a:r>
-              <a:rPr lang="en-US" sz="4400" b="0" i="0" u="none" strike="noStrike" cap="none" dirty="0" smtClean="0">
-                <a:solidFill>
-                  <a:srgbClr val="000000"/>
-                </a:solidFill>
-                <a:latin typeface="Merriweather"/>
-                <a:ea typeface="Merriweather"/>
-                <a:cs typeface="Merriweather"/>
-                <a:sym typeface="Merriweather"/>
-              </a:rPr>
-              <a:t>Best Practices</a:t>
-            </a:r>
-            <a:endParaRPr lang="en-US" sz="4400" b="0" i="0" u="none" strike="noStrike" cap="none" dirty="0">
-              <a:solidFill>
-                <a:srgbClr val="000000"/>
-              </a:solidFill>
-              <a:latin typeface="Merriweather"/>
-              <a:ea typeface="Merriweather"/>
-              <a:cs typeface="Merriweather"/>
-              <a:sym typeface="Merriweather"/>
-            </a:endParaRPr>
           </a:p>
         </p:txBody>
       </p:sp>
@@ -8134,7 +8131,7 @@
               <a:buNone/>
             </a:pPr>
             <a:r>
-              <a:rPr lang="en-US" sz="2000" b="0" i="0" u="none" strike="noStrike" cap="none" dirty="0" smtClean="0">
+              <a:rPr lang="en-US" sz="2000" b="0" i="0" u="none" strike="noStrike" cap="none" dirty="0">
                 <a:solidFill>
                   <a:srgbClr val="000000"/>
                 </a:solidFill>
@@ -8145,15 +8142,6 @@
               </a:rPr>
               <a:t>Do you really use Git efficiently?</a:t>
             </a:r>
-            <a:endParaRPr lang="en-US" sz="2000" b="0" i="0" u="none" strike="noStrike" cap="none" dirty="0">
-              <a:solidFill>
-                <a:srgbClr val="000000"/>
-              </a:solidFill>
-              <a:latin typeface="Arial"/>
-              <a:ea typeface="Arial"/>
-              <a:cs typeface="Arial"/>
-              <a:sym typeface="Arial"/>
-            </a:endParaRPr>
           </a:p>
           <a:p>
             <a:pPr marL="0" marR="0" lvl="0" indent="0" algn="l" rtl="0">
@@ -8233,7 +8221,7 @@
               <a:buNone/>
             </a:pPr>
             <a:r>
-              <a:rPr lang="en-US" sz="2000" b="0" i="0" u="none" strike="noStrike" cap="none" dirty="0" smtClean="0">
+              <a:rPr lang="en-US" sz="2000" b="0" i="0" u="none" strike="noStrike" cap="none" dirty="0">
                 <a:solidFill>
                   <a:srgbClr val="000000"/>
                 </a:solidFill>
@@ -8242,20 +8230,17 @@
                 <a:cs typeface="Merriweather"/>
                 <a:sym typeface="Merriweather"/>
               </a:rPr>
-              <a:t>201</a:t>
+              <a:t>2023</a:t>
             </a:r>
-            <a:r>
-              <a:rPr lang="en-US" sz="2000" b="0" dirty="0">
-                <a:solidFill>
-                  <a:srgbClr val="000000"/>
-                </a:solidFill>
-                <a:latin typeface="Merriweather"/>
-                <a:ea typeface="Merriweather"/>
-                <a:cs typeface="Merriweather"/>
-                <a:sym typeface="Merriweather"/>
-              </a:rPr>
-              <a:t>9</a:t>
-            </a:r>
+            <a:endParaRPr lang="en-US" sz="2000" b="0" dirty="0">
+              <a:solidFill>
+                <a:srgbClr val="000000"/>
+              </a:solidFill>
+              <a:latin typeface="Merriweather"/>
+              <a:ea typeface="Merriweather"/>
+              <a:cs typeface="Merriweather"/>
+              <a:sym typeface="Merriweather"/>
+            </a:endParaRPr>
           </a:p>
         </p:txBody>
       </p:sp>
@@ -8391,18 +8376,6 @@
                 <a:sym typeface="Arial"/>
               </a:rPr>
             </a:br>
-            <a:r>
-              <a:rPr lang="en-US" sz="3400" b="0" i="0" u="none" strike="noStrike" cap="none">
-                <a:solidFill>
-                  <a:schemeClr val="dk2"/>
-                </a:solidFill>
-                <a:latin typeface="Arial"/>
-                <a:ea typeface="Arial"/>
-                <a:cs typeface="Arial"/>
-                <a:sym typeface="Arial"/>
-              </a:rPr>
-              <a:t/>
-            </a:r>
             <a:br>
               <a:rPr lang="en-US" sz="3400" b="0" i="0" u="none" strike="noStrike" cap="none">
                 <a:solidFill>
@@ -8741,7 +8714,7 @@
               <a:buNone/>
             </a:pPr>
             <a:r>
-              <a:rPr lang="en-US" sz="4400" b="0" i="0" u="none" strike="noStrike" cap="none" dirty="0" smtClean="0">
+              <a:rPr lang="en-US" sz="4400" b="0" i="0" u="none" strike="noStrike" cap="none" dirty="0">
                 <a:solidFill>
                   <a:schemeClr val="dk2"/>
                 </a:solidFill>
@@ -8752,66 +8725,45 @@
               </a:rPr>
               <a:t>Question?</a:t>
             </a:r>
-            <a:r>
-              <a:rPr lang="en-US" sz="4400" dirty="0" smtClean="0"/>
-              <a:t/>
-            </a:r>
             <a:br>
-              <a:rPr lang="en-US" sz="4400" dirty="0" smtClean="0"/>
+              <a:rPr lang="en-US" sz="4400" dirty="0"/>
+            </a:br>
+            <a:br>
+              <a:rPr lang="en-US" sz="4400" dirty="0"/>
+            </a:br>
+            <a:br>
+              <a:rPr lang="en-US" sz="4400" dirty="0"/>
             </a:br>
             <a:r>
-              <a:rPr lang="en-US" sz="4400" dirty="0" smtClean="0"/>
-              <a:t/>
-            </a:r>
-            <a:br>
-              <a:rPr lang="en-US" sz="4400" dirty="0" smtClean="0"/>
-            </a:br>
-            <a:r>
-              <a:rPr lang="en-US" sz="4400" dirty="0" smtClean="0"/>
-              <a:t/>
-            </a:r>
-            <a:br>
-              <a:rPr lang="en-US" sz="4400" dirty="0" smtClean="0"/>
-            </a:br>
-            <a:r>
-              <a:rPr lang="en-US" sz="4400" dirty="0" smtClean="0"/>
+              <a:rPr lang="en-US" sz="4400" dirty="0"/>
               <a:t>Ilya Rokhkin (Git Trainings)</a:t>
             </a:r>
             <a:br>
-              <a:rPr lang="en-US" sz="4400" dirty="0" smtClean="0"/>
+              <a:rPr lang="en-US" sz="4400" dirty="0"/>
             </a:br>
             <a:r>
-              <a:rPr lang="en-US" sz="4400" dirty="0" smtClean="0">
+              <a:rPr lang="en-US" sz="4400" dirty="0">
                 <a:hlinkClick r:id="rId3"/>
               </a:rPr>
               <a:t>rokhkin_ilya@yahoo.com</a:t>
             </a:r>
-            <a:r>
-              <a:rPr lang="en-US" sz="4400" dirty="0" smtClean="0"/>
-              <a:t/>
-            </a:r>
             <a:br>
-              <a:rPr lang="en-US" sz="4400" dirty="0" smtClean="0"/>
+              <a:rPr lang="en-US" sz="4400" dirty="0"/>
             </a:br>
             <a:r>
-              <a:rPr lang="en-US" sz="4400" dirty="0" smtClean="0"/>
+              <a:rPr lang="en-US" sz="4400" dirty="0"/>
               <a:t>054-5224805</a:t>
             </a:r>
             <a:br>
-              <a:rPr lang="en-US" sz="4400" dirty="0" smtClean="0"/>
+              <a:rPr lang="en-US" sz="4400" dirty="0"/>
+            </a:br>
+            <a:br>
+              <a:rPr lang="en-US" sz="4400" dirty="0"/>
             </a:br>
             <a:r>
-              <a:rPr lang="en-US" sz="4400" dirty="0" smtClean="0"/>
-              <a:t/>
-            </a:r>
-            <a:br>
-              <a:rPr lang="en-US" sz="4400" dirty="0" smtClean="0"/>
-            </a:br>
-            <a:r>
-              <a:rPr lang="en-US" sz="4400" dirty="0" smtClean="0"/>
+              <a:rPr lang="en-US" sz="4400" dirty="0"/>
               <a:t>Thanks!</a:t>
             </a:r>
-            <a:endParaRPr lang="en-US" sz="4400" dirty="0"/>
           </a:p>
         </p:txBody>
       </p:sp>
@@ -9053,7 +9005,7 @@
               <a:buNone/>
             </a:pPr>
             <a:r>
-              <a:rPr lang="en-US" sz="3400" b="0" i="0" u="none" strike="noStrike" cap="none" dirty="0" smtClean="0">
+              <a:rPr lang="en-US" sz="3400" b="0" i="0" u="none" strike="noStrike" cap="none" dirty="0">
                 <a:solidFill>
                   <a:schemeClr val="dk2"/>
                 </a:solidFill>
@@ -9064,15 +9016,6 @@
               </a:rPr>
               <a:t>Git – meaning?</a:t>
             </a:r>
-            <a:endParaRPr lang="en-US" sz="3400" b="0" i="0" u="none" strike="noStrike" cap="none" dirty="0">
-              <a:solidFill>
-                <a:schemeClr val="dk2"/>
-              </a:solidFill>
-              <a:latin typeface="Arial"/>
-              <a:ea typeface="Arial"/>
-              <a:cs typeface="Arial"/>
-              <a:sym typeface="Arial"/>
-            </a:endParaRPr>
           </a:p>
         </p:txBody>
       </p:sp>
@@ -9100,10 +9043,9 @@
               <a:buNone/>
             </a:pPr>
             <a:r>
-              <a:rPr lang="en-US" sz="4000" dirty="0" smtClean="0"/>
-              <a:t>What does the word Git means?</a:t>
+              <a:rPr lang="en-US" sz="4000" dirty="0"/>
+              <a:t>What does the word Git mean?</a:t>
             </a:r>
-            <a:endParaRPr lang="en-US" sz="4000" dirty="0"/>
           </a:p>
         </p:txBody>
       </p:sp>
@@ -9450,31 +9392,7 @@
                 <a:cs typeface="Arial"/>
                 <a:sym typeface="Arial"/>
               </a:rPr>
-              <a:t>Best practices – local feature </a:t>
-            </a:r>
-            <a:r>
-              <a:rPr lang="en-US" sz="3400" b="0" i="0" u="none" strike="noStrike" cap="none" dirty="0" smtClean="0">
-                <a:solidFill>
-                  <a:schemeClr val="dk2"/>
-                </a:solidFill>
-                <a:latin typeface="Arial"/>
-                <a:ea typeface="Arial"/>
-                <a:cs typeface="Arial"/>
-                <a:sym typeface="Arial"/>
-              </a:rPr>
-              <a:t>branches (topics)</a:t>
-            </a:r>
-            <a:r>
-              <a:rPr lang="en-US" sz="3400" b="0" i="0" u="none" strike="noStrike" cap="none" dirty="0">
-                <a:solidFill>
-                  <a:schemeClr val="dk2"/>
-                </a:solidFill>
-                <a:latin typeface="Arial"/>
-                <a:ea typeface="Arial"/>
-                <a:cs typeface="Arial"/>
-                <a:sym typeface="Arial"/>
-              </a:rPr>
-              <a:t/>
+              <a:t>Best practices – local feature branches (topics)</a:t>
             </a:r>
             <a:br>
               <a:rPr lang="en-US" sz="3400" b="0" i="0" u="none" strike="noStrike" cap="none" dirty="0">
@@ -9487,18 +9405,6 @@
                 <a:sym typeface="Arial"/>
               </a:rPr>
             </a:br>
-            <a:r>
-              <a:rPr lang="en-US" sz="3400" b="0" i="0" u="none" strike="noStrike" cap="none" dirty="0">
-                <a:solidFill>
-                  <a:schemeClr val="dk2"/>
-                </a:solidFill>
-                <a:latin typeface="Arial"/>
-                <a:ea typeface="Arial"/>
-                <a:cs typeface="Arial"/>
-                <a:sym typeface="Arial"/>
-              </a:rPr>
-              <a:t/>
-            </a:r>
             <a:br>
               <a:rPr lang="en-US" sz="3400" b="0" i="0" u="none" strike="noStrike" cap="none" dirty="0">
                 <a:solidFill>
@@ -9737,10 +9643,9 @@
           <a:lstStyle/>
           <a:p>
             <a:r>
-              <a:rPr lang="en-US" dirty="0" smtClean="0"/>
+              <a:rPr lang="en-US" dirty="0"/>
               <a:t>Demo: create feature branch, checkout, commit </a:t>
             </a:r>
-            <a:endParaRPr lang="en-US" dirty="0"/>
           </a:p>
         </p:txBody>
       </p:sp>
@@ -9749,13 +9654,6 @@
   <p:clrMapOvr>
     <a:masterClrMapping/>
   </p:clrMapOvr>
-  <p:timing>
-    <p:tnLst>
-      <p:par>
-        <p:cTn id="1" dur="indefinite" restart="never" nodeType="tmRoot"/>
-      </p:par>
-    </p:tnLst>
-  </p:timing>
 </p:sld>
 </file>
 
@@ -9845,18 +9743,6 @@
                 <a:sym typeface="Arial"/>
               </a:rPr>
             </a:br>
-            <a:r>
-              <a:rPr lang="en-US" sz="3400" b="0" i="0" u="none" strike="noStrike" cap="none">
-                <a:solidFill>
-                  <a:schemeClr val="dk2"/>
-                </a:solidFill>
-                <a:latin typeface="Arial"/>
-                <a:ea typeface="Arial"/>
-                <a:cs typeface="Arial"/>
-                <a:sym typeface="Arial"/>
-              </a:rPr>
-              <a:t/>
-            </a:r>
             <a:br>
               <a:rPr lang="en-US" sz="3400" b="0" i="0" u="none" strike="noStrike" cap="none">
                 <a:solidFill>
@@ -10095,10 +9981,9 @@
           <a:lstStyle/>
           <a:p>
             <a:r>
-              <a:rPr lang="en-US" sz="2400" dirty="0" smtClean="0"/>
+              <a:rPr lang="en-US" sz="2400" dirty="0"/>
               <a:t>Demo: vim, change, commit, auto-commit, git log –c, git reset </a:t>
             </a:r>
-            <a:endParaRPr lang="en-US" sz="2400" dirty="0"/>
           </a:p>
         </p:txBody>
       </p:sp>
@@ -10107,13 +9992,6 @@
   <p:clrMapOvr>
     <a:masterClrMapping/>
   </p:clrMapOvr>
-  <p:timing>
-    <p:tnLst>
-      <p:par>
-        <p:cTn id="1" dur="indefinite" restart="never" nodeType="tmRoot"/>
-      </p:par>
-    </p:tnLst>
-  </p:timing>
 </p:sld>
 </file>
 
@@ -10203,18 +10081,6 @@
                 <a:sym typeface="Arial"/>
               </a:rPr>
             </a:br>
-            <a:r>
-              <a:rPr lang="en-US" sz="3400" b="0" i="0" u="none" strike="noStrike" cap="none">
-                <a:solidFill>
-                  <a:schemeClr val="dk2"/>
-                </a:solidFill>
-                <a:latin typeface="Arial"/>
-                <a:ea typeface="Arial"/>
-                <a:cs typeface="Arial"/>
-                <a:sym typeface="Arial"/>
-              </a:rPr>
-              <a:t/>
-            </a:r>
             <a:br>
               <a:rPr lang="en-US" sz="3400" b="0" i="0" u="none" strike="noStrike" cap="none">
                 <a:solidFill>
@@ -10415,14 +10281,9 @@
           <a:lstStyle/>
           <a:p>
             <a:r>
-              <a:rPr lang="en-US" sz="2400" dirty="0" smtClean="0"/>
-              <a:t>Demo: git </a:t>
+              <a:rPr lang="en-US" sz="2400" dirty="0"/>
+              <a:t>Demo: git merge --squash</a:t>
             </a:r>
-            <a:r>
-              <a:rPr lang="en-US" sz="2400" dirty="0" smtClean="0"/>
-              <a:t>merge --squash</a:t>
-            </a:r>
-            <a:endParaRPr lang="en-US" sz="2400" dirty="0"/>
           </a:p>
         </p:txBody>
       </p:sp>
@@ -10469,13 +10330,6 @@
   <p:clrMapOvr>
     <a:masterClrMapping/>
   </p:clrMapOvr>
-  <p:timing>
-    <p:tnLst>
-      <p:par>
-        <p:cTn id="1" dur="indefinite" restart="never" nodeType="tmRoot"/>
-      </p:par>
-    </p:tnLst>
-  </p:timing>
 </p:sld>
 </file>
 
@@ -10554,18 +10408,6 @@
               </a:rPr>
               <a:t>Best practices – clean up local branches</a:t>
             </a:r>
-            <a:r>
-              <a:rPr lang="en-US" sz="2400" b="0" i="0" u="none" strike="noStrike" cap="none">
-                <a:solidFill>
-                  <a:schemeClr val="dk2"/>
-                </a:solidFill>
-                <a:latin typeface="Arial"/>
-                <a:ea typeface="Arial"/>
-                <a:cs typeface="Arial"/>
-                <a:sym typeface="Arial"/>
-              </a:rPr>
-              <a:t/>
-            </a:r>
             <a:br>
               <a:rPr lang="en-US" sz="2400" b="0" i="0" u="none" strike="noStrike" cap="none">
                 <a:solidFill>
@@ -10783,13 +10625,6 @@
   <p:clrMapOvr>
     <a:masterClrMapping/>
   </p:clrMapOvr>
-  <p:timing>
-    <p:tnLst>
-      <p:par>
-        <p:cTn id="1" dur="indefinite" restart="never" nodeType="tmRoot"/>
-      </p:par>
-    </p:tnLst>
-  </p:timing>
 </p:sld>
 </file>
 
@@ -10898,44 +10733,15 @@
           <a:lstStyle/>
           <a:p>
             <a:r>
-              <a:rPr lang="en-US" sz="2400" dirty="0" smtClean="0"/>
-              <a:t>Limit commit message </a:t>
+              <a:rPr lang="en-US" sz="2400" dirty="0"/>
+              <a:t>Limit commit message Subject to 70 chars and it must be simple, clear, self explained – this is the line all will see!</a:t>
             </a:r>
+          </a:p>
+          <a:p>
             <a:r>
-              <a:rPr lang="en-US" sz="2400" dirty="0" smtClean="0"/>
-              <a:t>Subject </a:t>
+              <a:rPr lang="en-US" sz="2400" dirty="0"/>
+              <a:t>Meaningful details put in the body of the commit message</a:t>
             </a:r>
-            <a:r>
-              <a:rPr lang="en-US" sz="2400" dirty="0" smtClean="0"/>
-              <a:t>to 70 chars and it must be simple, clear, self explained – this is the line all will see!</a:t>
-            </a:r>
-          </a:p>
-          <a:p>
-            <a:r>
-              <a:rPr lang="en-US" sz="2400" dirty="0" smtClean="0"/>
-              <a:t>Meaningful details </a:t>
-            </a:r>
-            <a:r>
-              <a:rPr lang="en-US" sz="2400" dirty="0" smtClean="0"/>
-              <a:t>put in </a:t>
-            </a:r>
-            <a:r>
-              <a:rPr lang="en-US" sz="2400" dirty="0" smtClean="0"/>
-              <a:t>the </a:t>
-            </a:r>
-            <a:r>
-              <a:rPr lang="en-US" sz="2400" dirty="0" smtClean="0"/>
-              <a:t>body of </a:t>
-            </a:r>
-            <a:r>
-              <a:rPr lang="en-US" sz="2400" dirty="0" smtClean="0"/>
-              <a:t>the </a:t>
-            </a:r>
-            <a:r>
-              <a:rPr lang="en-US" sz="2400" dirty="0" smtClean="0"/>
-              <a:t>commit message</a:t>
-            </a:r>
-            <a:endParaRPr lang="en-US" sz="2400" dirty="0"/>
           </a:p>
         </p:txBody>
       </p:sp>
@@ -10962,7 +10768,7 @@
           <a:lstStyle/>
           <a:p>
             <a:r>
-              <a:rPr lang="en-US" sz="2000" dirty="0" smtClean="0">
+              <a:rPr lang="en-US" sz="2000" dirty="0">
                 <a:hlinkClick r:id="rId4"/>
               </a:rPr>
               <a:t>https://github.com/datreeio/node-datreeio/commits/master</a:t>
@@ -10994,10 +10800,9 @@
           <a:lstStyle/>
           <a:p>
             <a:r>
-              <a:rPr lang="en-US" sz="2000" dirty="0" smtClean="0"/>
+              <a:rPr lang="en-US" sz="2000" dirty="0"/>
               <a:t>Demo: Example:</a:t>
             </a:r>
-            <a:endParaRPr lang="en-US" sz="2000" dirty="0"/>
           </a:p>
         </p:txBody>
       </p:sp>
@@ -11044,13 +10849,6 @@
   <p:clrMapOvr>
     <a:masterClrMapping/>
   </p:clrMapOvr>
-  <p:timing>
-    <p:tnLst>
-      <p:par>
-        <p:cTn id="1" dur="indefinite" restart="never" nodeType="tmRoot"/>
-      </p:par>
-    </p:tnLst>
-  </p:timing>
 </p:sld>
 </file>
 
@@ -11268,13 +11066,6 @@
   <p:clrMapOvr>
     <a:masterClrMapping/>
   </p:clrMapOvr>
-  <p:timing>
-    <p:tnLst>
-      <p:par>
-        <p:cTn id="1" dur="indefinite" restart="never" nodeType="tmRoot"/>
-      </p:par>
-    </p:tnLst>
-  </p:timing>
 </p:sld>
 </file>
 
@@ -11838,4 +11629,10 @@
   <a:objectDefaults/>
   <a:extraClrSchemeLst/>
 </a:theme>
+</file>
+
+<file path=docMetadata/LabelInfo.xml><?xml version="1.0" encoding="utf-8"?>
+<clbl:labelList xmlns:clbl="http://schemas.microsoft.com/office/2020/mipLabelMetadata">
+  <clbl:label id="{e0cf9a1c-2cb1-4d38-9733-321b2d511f49}" enabled="1" method="Standard" siteId="{612a5289-89a8-45c2-a40d-f36fadb6d37c}" contentBits="0" removed="0"/>
+</clbl:labelList>
 </file>
</xml_diff>